<commit_message>
Fix duplicate effect lists that stopped PowerPoint opening the slide
Co-Authored-By: Claude Opus 5.5 <noreply@anthropic.com>
Claude-Session: https://claude.ai/code/session_01PrHcnkKAEYKXWTTmXwePFz
</commit_message>
<xml_diff>
--- a/Applying_Power_Apps_Slide.pptx
+++ b/Applying_Power_Apps_Slide.pptx
@@ -3521,7 +3521,6 @@
               <a:srgbClr val="E1E6EE"/>
             </a:solidFill>
           </a:ln>
-          <a:effectLst/>
           <a:effectLst>
             <a:outerShdw blurRad="190500" dist="38100" dir="5400000" algn="t" rotWithShape="0">
               <a:srgbClr val="1F3A68">
@@ -5584,7 +5583,6 @@
               <a:srgbClr val="F08A2C"/>
             </a:solidFill>
           </a:ln>
-          <a:effectLst/>
           <a:effectLst>
             <a:glow rad="76200">
               <a:srgbClr val="F08A2C">
@@ -5774,7 +5772,6 @@
               <a:srgbClr val="3B8BEA"/>
             </a:solidFill>
           </a:ln>
-          <a:effectLst/>
           <a:effectLst>
             <a:glow rad="76200">
               <a:srgbClr val="3B8BEA">
@@ -5964,7 +5961,6 @@
               <a:srgbClr val="2DB45A"/>
             </a:solidFill>
           </a:ln>
-          <a:effectLst/>
           <a:effectLst>
             <a:glow rad="76200">
               <a:srgbClr val="2DB45A">
@@ -6273,7 +6269,6 @@
               <a:srgbClr val="3CC57E"/>
             </a:solidFill>
           </a:ln>
-          <a:effectLst/>
           <a:effectLst>
             <a:glow rad="76200">
               <a:srgbClr val="2FBF71">

</xml_diff>